<commit_message>
update narasi untuk slide demo
</commit_message>
<xml_diff>
--- a/UTS_NPA_Kelompok_5.pptx
+++ b/UTS_NPA_Kelompok_5.pptx
@@ -2515,7 +2515,151 @@
                 <a:ea typeface="+mn-ea"/>
                 <a:cs typeface="+mn-cs"/>
               </a:rPr>
-              <a:t>Server </a:t>
+              <a:t>Sama </a:t>
+            </a:r>
+            <a:r>
+              <a:rPr lang="en-ID" sz="1200" b="0" i="0" kern="1200" dirty="0" err="1">
+                <a:solidFill>
+                  <a:schemeClr val="tx1"/>
+                </a:solidFill>
+                <a:effectLst/>
+                <a:latin typeface="+mn-lt"/>
+                <a:ea typeface="+mn-ea"/>
+                <a:cs typeface="+mn-cs"/>
+              </a:rPr>
+              <a:t>seperti</a:t>
+            </a:r>
+            <a:r>
+              <a:rPr lang="en-ID" sz="1200" b="0" i="0" kern="1200" dirty="0">
+                <a:solidFill>
+                  <a:schemeClr val="tx1"/>
+                </a:solidFill>
+                <a:effectLst/>
+                <a:latin typeface="+mn-lt"/>
+                <a:ea typeface="+mn-ea"/>
+                <a:cs typeface="+mn-cs"/>
+              </a:rPr>
+              <a:t> </a:t>
+            </a:r>
+            <a:r>
+              <a:rPr lang="en-ID" sz="1200" b="0" i="0" kern="1200" dirty="0" err="1">
+                <a:solidFill>
+                  <a:schemeClr val="tx1"/>
+                </a:solidFill>
+                <a:effectLst/>
+                <a:latin typeface="+mn-lt"/>
+                <a:ea typeface="+mn-ea"/>
+                <a:cs typeface="+mn-cs"/>
+              </a:rPr>
+              <a:t>tadi</a:t>
+            </a:r>
+            <a:r>
+              <a:rPr lang="en-ID" sz="1200" b="0" i="0" kern="1200" dirty="0">
+                <a:solidFill>
+                  <a:schemeClr val="tx1"/>
+                </a:solidFill>
+                <a:effectLst/>
+                <a:latin typeface="+mn-lt"/>
+                <a:ea typeface="+mn-ea"/>
+                <a:cs typeface="+mn-cs"/>
+              </a:rPr>
+              <a:t>, sniffer Wireshark </a:t>
+            </a:r>
+            <a:r>
+              <a:rPr lang="en-ID" sz="1200" b="0" i="0" kern="1200" dirty="0" err="1">
+                <a:solidFill>
+                  <a:schemeClr val="tx1"/>
+                </a:solidFill>
+                <a:effectLst/>
+                <a:latin typeface="+mn-lt"/>
+                <a:ea typeface="+mn-ea"/>
+                <a:cs typeface="+mn-cs"/>
+              </a:rPr>
+              <a:t>sudah</a:t>
+            </a:r>
+            <a:r>
+              <a:rPr lang="en-ID" sz="1200" b="0" i="0" kern="1200" dirty="0">
+                <a:solidFill>
+                  <a:schemeClr val="tx1"/>
+                </a:solidFill>
+                <a:effectLst/>
+                <a:latin typeface="+mn-lt"/>
+                <a:ea typeface="+mn-ea"/>
+                <a:cs typeface="+mn-cs"/>
+              </a:rPr>
+              <a:t> </a:t>
+            </a:r>
+            <a:r>
+              <a:rPr lang="en-ID" sz="1200" b="0" i="0" kern="1200" dirty="0" err="1">
+                <a:solidFill>
+                  <a:schemeClr val="tx1"/>
+                </a:solidFill>
+                <a:effectLst/>
+                <a:latin typeface="+mn-lt"/>
+                <a:ea typeface="+mn-ea"/>
+                <a:cs typeface="+mn-cs"/>
+              </a:rPr>
+              <a:t>siap</a:t>
+            </a:r>
+            <a:r>
+              <a:rPr lang="en-ID" sz="1200" b="0" i="0" kern="1200" dirty="0">
+                <a:solidFill>
+                  <a:schemeClr val="tx1"/>
+                </a:solidFill>
+                <a:effectLst/>
+                <a:latin typeface="+mn-lt"/>
+                <a:ea typeface="+mn-ea"/>
+                <a:cs typeface="+mn-cs"/>
+              </a:rPr>
+              <a:t> </a:t>
+            </a:r>
+            <a:r>
+              <a:rPr lang="en-ID" sz="1200" b="0" i="0" kern="1200" dirty="0" err="1">
+                <a:solidFill>
+                  <a:schemeClr val="tx1"/>
+                </a:solidFill>
+                <a:effectLst/>
+                <a:latin typeface="+mn-lt"/>
+                <a:ea typeface="+mn-ea"/>
+                <a:cs typeface="+mn-cs"/>
+              </a:rPr>
+              <a:t>sedia</a:t>
+            </a:r>
+            <a:r>
+              <a:rPr lang="en-ID" sz="1200" b="0" i="0" kern="1200" dirty="0">
+                <a:solidFill>
+                  <a:schemeClr val="tx1"/>
+                </a:solidFill>
+                <a:effectLst/>
+                <a:latin typeface="+mn-lt"/>
+                <a:ea typeface="+mn-ea"/>
+                <a:cs typeface="+mn-cs"/>
+              </a:rPr>
+              <a:t>. Server </a:t>
+            </a:r>
+            <a:r>
+              <a:rPr lang="en-ID" sz="1200" b="0" i="0" kern="1200" dirty="0" err="1">
+                <a:solidFill>
+                  <a:schemeClr val="tx1"/>
+                </a:solidFill>
+                <a:effectLst/>
+                <a:latin typeface="+mn-lt"/>
+                <a:ea typeface="+mn-ea"/>
+                <a:cs typeface="+mn-cs"/>
+              </a:rPr>
+              <a:t>kini</a:t>
+            </a:r>
+            <a:r>
+              <a:rPr lang="en-ID" sz="1200" b="0" i="0" kern="1200" dirty="0">
+                <a:solidFill>
+                  <a:schemeClr val="tx1"/>
+                </a:solidFill>
+                <a:effectLst/>
+                <a:latin typeface="+mn-lt"/>
+                <a:ea typeface="+mn-ea"/>
+                <a:cs typeface="+mn-cs"/>
+              </a:rPr>
+              <a:t> </a:t>
             </a:r>
             <a:r>
               <a:rPr lang="en-ID" sz="1200" b="0" i="0" kern="1200" dirty="0" err="1">
@@ -2588,6 +2732,30 @@
                 <a:cs typeface="+mn-cs"/>
               </a:rPr>
               <a:t> client, </a:t>
+            </a:r>
+            <a:r>
+              <a:rPr lang="en-ID" sz="1200" b="0" i="0" kern="1200" dirty="0" err="1">
+                <a:solidFill>
+                  <a:schemeClr val="tx1"/>
+                </a:solidFill>
+                <a:effectLst/>
+                <a:latin typeface="+mn-lt"/>
+                <a:ea typeface="+mn-ea"/>
+                <a:cs typeface="+mn-cs"/>
+              </a:rPr>
+              <a:t>lalu</a:t>
+            </a:r>
+            <a:r>
+              <a:rPr lang="en-ID" sz="1200" b="0" i="0" kern="1200" dirty="0">
+                <a:solidFill>
+                  <a:schemeClr val="tx1"/>
+                </a:solidFill>
+                <a:effectLst/>
+                <a:latin typeface="+mn-lt"/>
+                <a:ea typeface="+mn-ea"/>
+                <a:cs typeface="+mn-cs"/>
+              </a:rPr>
+              <a:t> </a:t>
             </a:r>
             <a:r>
               <a:rPr lang="en-ID" sz="1200" b="0" i="0" kern="1200" dirty="0" err="1">
@@ -2817,19 +2985,115 @@
                 <a:ea typeface="+mn-ea"/>
                 <a:cs typeface="+mn-cs"/>
               </a:rPr>
-              <a:t>Sekarang</a:t>
-            </a:r>
-            <a:r>
-              <a:rPr lang="en-ID" sz="1200" b="0" i="0" kern="1200" dirty="0">
-                <a:solidFill>
-                  <a:schemeClr val="tx1"/>
-                </a:solidFill>
-                <a:effectLst/>
-                <a:latin typeface="+mn-lt"/>
-                <a:ea typeface="+mn-ea"/>
-                <a:cs typeface="+mn-cs"/>
-              </a:rPr>
-              <a:t> Wireshark — Follow TCP Stream — dan </a:t>
+              <a:t>Jendela</a:t>
+            </a:r>
+            <a:r>
+              <a:rPr lang="en-ID" sz="1200" b="0" i="0" kern="1200" dirty="0">
+                <a:solidFill>
+                  <a:schemeClr val="tx1"/>
+                </a:solidFill>
+                <a:effectLst/>
+                <a:latin typeface="+mn-lt"/>
+                <a:ea typeface="+mn-ea"/>
+                <a:cs typeface="+mn-cs"/>
+              </a:rPr>
+              <a:t> Wireshark </a:t>
+            </a:r>
+            <a:r>
+              <a:rPr lang="en-ID" sz="1200" b="0" i="0" kern="1200" dirty="0" err="1">
+                <a:solidFill>
+                  <a:schemeClr val="tx1"/>
+                </a:solidFill>
+                <a:effectLst/>
+                <a:latin typeface="+mn-lt"/>
+                <a:ea typeface="+mn-ea"/>
+                <a:cs typeface="+mn-cs"/>
+              </a:rPr>
+              <a:t>kembali</a:t>
+            </a:r>
+            <a:r>
+              <a:rPr lang="en-ID" sz="1200" b="0" i="0" kern="1200" dirty="0">
+                <a:solidFill>
+                  <a:schemeClr val="tx1"/>
+                </a:solidFill>
+                <a:effectLst/>
+                <a:latin typeface="+mn-lt"/>
+                <a:ea typeface="+mn-ea"/>
+                <a:cs typeface="+mn-cs"/>
+              </a:rPr>
+              <a:t> </a:t>
+            </a:r>
+            <a:r>
+              <a:rPr lang="en-ID" sz="1200" b="0" i="0" kern="1200" dirty="0" err="1">
+                <a:solidFill>
+                  <a:schemeClr val="tx1"/>
+                </a:solidFill>
+                <a:effectLst/>
+                <a:latin typeface="+mn-lt"/>
+                <a:ea typeface="+mn-ea"/>
+                <a:cs typeface="+mn-cs"/>
+              </a:rPr>
+              <a:t>menangkap</a:t>
+            </a:r>
+            <a:r>
+              <a:rPr lang="en-ID" sz="1200" b="0" i="0" kern="1200" dirty="0">
+                <a:solidFill>
+                  <a:schemeClr val="tx1"/>
+                </a:solidFill>
+                <a:effectLst/>
+                <a:latin typeface="+mn-lt"/>
+                <a:ea typeface="+mn-ea"/>
+                <a:cs typeface="+mn-cs"/>
+              </a:rPr>
+              <a:t> </a:t>
+            </a:r>
+            <a:r>
+              <a:rPr lang="en-ID" sz="1200" b="0" i="0" kern="1200" dirty="0" err="1">
+                <a:solidFill>
+                  <a:schemeClr val="tx1"/>
+                </a:solidFill>
+                <a:effectLst/>
+                <a:latin typeface="+mn-lt"/>
+                <a:ea typeface="+mn-ea"/>
+                <a:cs typeface="+mn-cs"/>
+              </a:rPr>
+              <a:t>paketnya</a:t>
+            </a:r>
+            <a:r>
+              <a:rPr lang="en-ID" sz="1200" b="0" i="0" kern="1200" dirty="0">
+                <a:solidFill>
+                  <a:schemeClr val="tx1"/>
+                </a:solidFill>
+                <a:effectLst/>
+                <a:latin typeface="+mn-lt"/>
+                <a:ea typeface="+mn-ea"/>
+                <a:cs typeface="+mn-cs"/>
+              </a:rPr>
+              <a:t>. Mari </a:t>
+            </a:r>
+            <a:r>
+              <a:rPr lang="en-ID" sz="1200" b="0" i="0" kern="1200" dirty="0" err="1">
+                <a:solidFill>
+                  <a:schemeClr val="tx1"/>
+                </a:solidFill>
+                <a:effectLst/>
+                <a:latin typeface="+mn-lt"/>
+                <a:ea typeface="+mn-ea"/>
+                <a:cs typeface="+mn-cs"/>
+              </a:rPr>
+              <a:t>kita</a:t>
+            </a:r>
+            <a:r>
+              <a:rPr lang="en-ID" sz="1200" b="0" i="0" kern="1200" dirty="0">
+                <a:solidFill>
+                  <a:schemeClr val="tx1"/>
+                </a:solidFill>
+                <a:effectLst/>
+                <a:latin typeface="+mn-lt"/>
+                <a:ea typeface="+mn-ea"/>
+                <a:cs typeface="+mn-cs"/>
+              </a:rPr>
+              <a:t> Follow TCP Stream — dan </a:t>
             </a:r>
             <a:r>
               <a:rPr lang="en-ID" sz="1200" b="0" i="0" kern="1200" dirty="0" err="1">
@@ -3177,7 +3441,7 @@
                 <a:ea typeface="+mn-ea"/>
                 <a:cs typeface="+mn-cs"/>
               </a:rPr>
-              <a:t>ditangkap</a:t>
+              <a:t>disadap</a:t>
             </a:r>
             <a:r>
               <a:rPr lang="en-ID" sz="1200" b="0" i="0" kern="1200" dirty="0">
@@ -3225,6 +3489,54 @@
                 <a:ea typeface="+mn-ea"/>
                 <a:cs typeface="+mn-cs"/>
               </a:rPr>
+              <a:t>sama</a:t>
+            </a:r>
+            <a:r>
+              <a:rPr lang="en-ID" sz="1200" b="0" i="0" kern="1200" dirty="0">
+                <a:solidFill>
+                  <a:schemeClr val="tx1"/>
+                </a:solidFill>
+                <a:effectLst/>
+                <a:latin typeface="+mn-lt"/>
+                <a:ea typeface="+mn-ea"/>
+                <a:cs typeface="+mn-cs"/>
+              </a:rPr>
+              <a:t> </a:t>
+            </a:r>
+            <a:r>
+              <a:rPr lang="en-ID" sz="1200" b="0" i="0" kern="1200" dirty="0" err="1">
+                <a:solidFill>
+                  <a:schemeClr val="tx1"/>
+                </a:solidFill>
+                <a:effectLst/>
+                <a:latin typeface="+mn-lt"/>
+                <a:ea typeface="+mn-ea"/>
+                <a:cs typeface="+mn-cs"/>
+              </a:rPr>
+              <a:t>sekali</a:t>
+            </a:r>
+            <a:r>
+              <a:rPr lang="en-ID" sz="1200" b="0" i="0" kern="1200" dirty="0">
+                <a:solidFill>
+                  <a:schemeClr val="tx1"/>
+                </a:solidFill>
+                <a:effectLst/>
+                <a:latin typeface="+mn-lt"/>
+                <a:ea typeface="+mn-ea"/>
+                <a:cs typeface="+mn-cs"/>
+              </a:rPr>
+              <a:t> </a:t>
+            </a:r>
+            <a:r>
+              <a:rPr lang="en-ID" sz="1200" b="0" i="0" kern="1200" dirty="0" err="1">
+                <a:solidFill>
+                  <a:schemeClr val="tx1"/>
+                </a:solidFill>
+                <a:effectLst/>
+                <a:latin typeface="+mn-lt"/>
+                <a:ea typeface="+mn-ea"/>
+                <a:cs typeface="+mn-cs"/>
+              </a:rPr>
               <a:t>tidak</a:t>
             </a:r>
             <a:r>
@@ -3347,15 +3659,18 @@
               </a:rPr>
               <a:t>dekripsi</a:t>
             </a:r>
-            <a:endParaRPr lang="en-ID" sz="1200" b="0" i="0" kern="1200" dirty="0">
-              <a:solidFill>
-                <a:schemeClr val="tx1"/>
-              </a:solidFill>
-              <a:effectLst/>
-              <a:latin typeface="+mn-lt"/>
-              <a:ea typeface="+mn-ea"/>
-              <a:cs typeface="+mn-cs"/>
-            </a:endParaRPr>
+            <a:r>
+              <a:rPr lang="en-ID" sz="1200" b="0" i="0" kern="1200">
+                <a:solidFill>
+                  <a:schemeClr val="tx1"/>
+                </a:solidFill>
+                <a:effectLst/>
+                <a:latin typeface="+mn-lt"/>
+                <a:ea typeface="+mn-ea"/>
+                <a:cs typeface="+mn-cs"/>
+              </a:rPr>
+              <a:t>.</a:t>
+            </a:r>
           </a:p>
         </p:txBody>
       </p:sp>
@@ -14396,112 +14711,244 @@
           <a:lstStyle/>
           <a:p>
             <a:r>
-              <a:rPr lang="en-ID" sz="1200" b="0" i="0" kern="1200" dirty="0">
-                <a:solidFill>
-                  <a:schemeClr val="tx1"/>
-                </a:solidFill>
-                <a:effectLst/>
-                <a:latin typeface="+mn-lt"/>
-                <a:ea typeface="+mn-ea"/>
-                <a:cs typeface="+mn-cs"/>
-              </a:rPr>
-              <a:t>Wireshark </a:t>
-            </a:r>
-            <a:r>
-              <a:rPr lang="en-ID" sz="1200" b="0" i="0" kern="1200" dirty="0" err="1">
-                <a:solidFill>
-                  <a:schemeClr val="tx1"/>
-                </a:solidFill>
-                <a:effectLst/>
-                <a:latin typeface="+mn-lt"/>
-                <a:ea typeface="+mn-ea"/>
-                <a:cs typeface="+mn-cs"/>
-              </a:rPr>
-              <a:t>sudah</a:t>
-            </a:r>
-            <a:r>
-              <a:rPr lang="en-ID" sz="1200" b="0" i="0" kern="1200" dirty="0">
-                <a:solidFill>
-                  <a:schemeClr val="tx1"/>
-                </a:solidFill>
-                <a:effectLst/>
-                <a:latin typeface="+mn-lt"/>
-                <a:ea typeface="+mn-ea"/>
-                <a:cs typeface="+mn-cs"/>
-              </a:rPr>
-              <a:t> </a:t>
-            </a:r>
-            <a:r>
-              <a:rPr lang="en-ID" sz="1200" b="0" i="0" kern="1200" dirty="0" err="1">
-                <a:solidFill>
-                  <a:schemeClr val="tx1"/>
-                </a:solidFill>
-                <a:effectLst/>
-                <a:latin typeface="+mn-lt"/>
-                <a:ea typeface="+mn-ea"/>
-                <a:cs typeface="+mn-cs"/>
-              </a:rPr>
-              <a:t>berjalan</a:t>
-            </a:r>
-            <a:r>
-              <a:rPr lang="en-ID" sz="1200" b="0" i="0" kern="1200" dirty="0">
-                <a:solidFill>
-                  <a:schemeClr val="tx1"/>
-                </a:solidFill>
-                <a:effectLst/>
-                <a:latin typeface="+mn-lt"/>
-                <a:ea typeface="+mn-ea"/>
-                <a:cs typeface="+mn-cs"/>
-              </a:rPr>
-              <a:t> </a:t>
-            </a:r>
-            <a:r>
-              <a:rPr lang="en-ID" sz="1200" b="0" i="0" kern="1200" dirty="0" err="1">
-                <a:solidFill>
-                  <a:schemeClr val="tx1"/>
-                </a:solidFill>
-                <a:effectLst/>
-                <a:latin typeface="+mn-lt"/>
-                <a:ea typeface="+mn-ea"/>
-                <a:cs typeface="+mn-cs"/>
-              </a:rPr>
-              <a:t>dengan</a:t>
-            </a:r>
-            <a:r>
-              <a:rPr lang="en-ID" sz="1200" b="0" i="0" kern="1200" dirty="0">
-                <a:solidFill>
-                  <a:schemeClr val="tx1"/>
-                </a:solidFill>
-                <a:effectLst/>
-                <a:latin typeface="+mn-lt"/>
-                <a:ea typeface="+mn-ea"/>
-                <a:cs typeface="+mn-cs"/>
-              </a:rPr>
-              <a:t> filter </a:t>
-            </a:r>
-            <a:r>
-              <a:rPr lang="en-ID" sz="1200" b="0" i="0" kern="1200" dirty="0" err="1">
-                <a:solidFill>
-                  <a:schemeClr val="tx1"/>
-                </a:solidFill>
-                <a:effectLst/>
-                <a:latin typeface="+mn-lt"/>
-                <a:ea typeface="+mn-ea"/>
-                <a:cs typeface="+mn-cs"/>
-              </a:rPr>
-              <a:t>tcp.port</a:t>
-            </a:r>
-            <a:r>
-              <a:rPr lang="en-ID" sz="1200" b="0" i="0" kern="1200" dirty="0">
-                <a:solidFill>
-                  <a:schemeClr val="tx1"/>
-                </a:solidFill>
-                <a:effectLst/>
-                <a:latin typeface="+mn-lt"/>
-                <a:ea typeface="+mn-ea"/>
-                <a:cs typeface="+mn-cs"/>
-              </a:rPr>
-              <a:t> 12345. Saya </a:t>
+              <a:rPr lang="en-ID" sz="1200" b="0" i="0" kern="1200" dirty="0" err="1">
+                <a:solidFill>
+                  <a:schemeClr val="tx1"/>
+                </a:solidFill>
+                <a:effectLst/>
+                <a:latin typeface="+mn-lt"/>
+                <a:ea typeface="+mn-ea"/>
+                <a:cs typeface="+mn-cs"/>
+              </a:rPr>
+              <a:t>Untuk</a:t>
+            </a:r>
+            <a:r>
+              <a:rPr lang="en-ID" sz="1200" b="0" i="0" kern="1200" dirty="0">
+                <a:solidFill>
+                  <a:schemeClr val="tx1"/>
+                </a:solidFill>
+                <a:effectLst/>
+                <a:latin typeface="+mn-lt"/>
+                <a:ea typeface="+mn-ea"/>
+                <a:cs typeface="+mn-cs"/>
+              </a:rPr>
+              <a:t> </a:t>
+            </a:r>
+            <a:r>
+              <a:rPr lang="en-ID" sz="1200" b="0" i="0" kern="1200" dirty="0" err="1">
+                <a:solidFill>
+                  <a:schemeClr val="tx1"/>
+                </a:solidFill>
+                <a:effectLst/>
+                <a:latin typeface="+mn-lt"/>
+                <a:ea typeface="+mn-ea"/>
+                <a:cs typeface="+mn-cs"/>
+              </a:rPr>
+              <a:t>menangkap</a:t>
+            </a:r>
+            <a:r>
+              <a:rPr lang="en-ID" sz="1200" b="0" i="0" kern="1200" dirty="0">
+                <a:solidFill>
+                  <a:schemeClr val="tx1"/>
+                </a:solidFill>
+                <a:effectLst/>
+                <a:latin typeface="+mn-lt"/>
+                <a:ea typeface="+mn-ea"/>
+                <a:cs typeface="+mn-cs"/>
+              </a:rPr>
+              <a:t> </a:t>
+            </a:r>
+            <a:r>
+              <a:rPr lang="en-ID" sz="1200" b="0" i="0" kern="1200" dirty="0" err="1">
+                <a:solidFill>
+                  <a:schemeClr val="tx1"/>
+                </a:solidFill>
+                <a:effectLst/>
+                <a:latin typeface="+mn-lt"/>
+                <a:ea typeface="+mn-ea"/>
+                <a:cs typeface="+mn-cs"/>
+              </a:rPr>
+              <a:t>lalu</a:t>
+            </a:r>
+            <a:r>
+              <a:rPr lang="en-ID" sz="1200" b="0" i="0" kern="1200" dirty="0">
+                <a:solidFill>
+                  <a:schemeClr val="tx1"/>
+                </a:solidFill>
+                <a:effectLst/>
+                <a:latin typeface="+mn-lt"/>
+                <a:ea typeface="+mn-ea"/>
+                <a:cs typeface="+mn-cs"/>
+              </a:rPr>
+              <a:t> </a:t>
+            </a:r>
+            <a:r>
+              <a:rPr lang="en-ID" sz="1200" b="0" i="0" kern="1200" dirty="0" err="1">
+                <a:solidFill>
+                  <a:schemeClr val="tx1"/>
+                </a:solidFill>
+                <a:effectLst/>
+                <a:latin typeface="+mn-lt"/>
+                <a:ea typeface="+mn-ea"/>
+                <a:cs typeface="+mn-cs"/>
+              </a:rPr>
+              <a:t>lintas</a:t>
+            </a:r>
+            <a:r>
+              <a:rPr lang="en-ID" sz="1200" b="0" i="0" kern="1200" dirty="0">
+                <a:solidFill>
+                  <a:schemeClr val="tx1"/>
+                </a:solidFill>
+                <a:effectLst/>
+                <a:latin typeface="+mn-lt"/>
+                <a:ea typeface="+mn-ea"/>
+                <a:cs typeface="+mn-cs"/>
+              </a:rPr>
+              <a:t> </a:t>
+            </a:r>
+            <a:r>
+              <a:rPr lang="en-ID" sz="1200" b="0" i="0" kern="1200" dirty="0" err="1">
+                <a:solidFill>
+                  <a:schemeClr val="tx1"/>
+                </a:solidFill>
+                <a:effectLst/>
+                <a:latin typeface="+mn-lt"/>
+                <a:ea typeface="+mn-ea"/>
+                <a:cs typeface="+mn-cs"/>
+              </a:rPr>
+              <a:t>jaringan</a:t>
+            </a:r>
+            <a:r>
+              <a:rPr lang="en-ID" sz="1200" b="0" i="0" kern="1200" dirty="0">
+                <a:solidFill>
+                  <a:schemeClr val="tx1"/>
+                </a:solidFill>
+                <a:effectLst/>
+                <a:latin typeface="+mn-lt"/>
+                <a:ea typeface="+mn-ea"/>
+                <a:cs typeface="+mn-cs"/>
+              </a:rPr>
+              <a:t>, </a:t>
+            </a:r>
+            <a:r>
+              <a:rPr lang="en-ID" sz="1200" b="0" i="0" kern="1200" dirty="0" err="1">
+                <a:solidFill>
+                  <a:schemeClr val="tx1"/>
+                </a:solidFill>
+                <a:effectLst/>
+                <a:latin typeface="+mn-lt"/>
+                <a:ea typeface="+mn-ea"/>
+                <a:cs typeface="+mn-cs"/>
+              </a:rPr>
+              <a:t>saya</a:t>
+            </a:r>
+            <a:r>
+              <a:rPr lang="en-ID" sz="1200" b="0" i="0" kern="1200" dirty="0">
+                <a:solidFill>
+                  <a:schemeClr val="tx1"/>
+                </a:solidFill>
+                <a:effectLst/>
+                <a:latin typeface="+mn-lt"/>
+                <a:ea typeface="+mn-ea"/>
+                <a:cs typeface="+mn-cs"/>
+              </a:rPr>
+              <a:t> </a:t>
+            </a:r>
+            <a:r>
+              <a:rPr lang="en-ID" sz="1200" b="0" i="0" kern="1200" dirty="0" err="1">
+                <a:solidFill>
+                  <a:schemeClr val="tx1"/>
+                </a:solidFill>
+                <a:effectLst/>
+                <a:latin typeface="+mn-lt"/>
+                <a:ea typeface="+mn-ea"/>
+                <a:cs typeface="+mn-cs"/>
+              </a:rPr>
+              <a:t>menggunakan</a:t>
+            </a:r>
+            <a:r>
+              <a:rPr lang="en-ID" sz="1200" b="0" i="0" kern="1200" dirty="0">
+                <a:solidFill>
+                  <a:schemeClr val="tx1"/>
+                </a:solidFill>
+                <a:effectLst/>
+                <a:latin typeface="+mn-lt"/>
+                <a:ea typeface="+mn-ea"/>
+                <a:cs typeface="+mn-cs"/>
+              </a:rPr>
+              <a:t> sniffer yang </a:t>
+            </a:r>
+            <a:r>
+              <a:rPr lang="en-ID" sz="1200" b="0" i="0" kern="1200" dirty="0" err="1">
+                <a:solidFill>
+                  <a:schemeClr val="tx1"/>
+                </a:solidFill>
+                <a:effectLst/>
+                <a:latin typeface="+mn-lt"/>
+                <a:ea typeface="+mn-ea"/>
+                <a:cs typeface="+mn-cs"/>
+              </a:rPr>
+              <a:t>langsung</a:t>
+            </a:r>
+            <a:r>
+              <a:rPr lang="en-ID" sz="1200" b="0" i="0" kern="1200" dirty="0">
+                <a:solidFill>
+                  <a:schemeClr val="tx1"/>
+                </a:solidFill>
+                <a:effectLst/>
+                <a:latin typeface="+mn-lt"/>
+                <a:ea typeface="+mn-ea"/>
+                <a:cs typeface="+mn-cs"/>
+              </a:rPr>
+              <a:t> </a:t>
+            </a:r>
+            <a:r>
+              <a:rPr lang="en-ID" sz="1200" b="0" i="0" kern="1200" dirty="0" err="1">
+                <a:solidFill>
+                  <a:schemeClr val="tx1"/>
+                </a:solidFill>
+                <a:effectLst/>
+                <a:latin typeface="+mn-lt"/>
+                <a:ea typeface="+mn-ea"/>
+                <a:cs typeface="+mn-cs"/>
+              </a:rPr>
+              <a:t>dialirkan</a:t>
+            </a:r>
+            <a:r>
+              <a:rPr lang="en-ID" sz="1200" b="0" i="0" kern="1200" dirty="0">
+                <a:solidFill>
+                  <a:schemeClr val="tx1"/>
+                </a:solidFill>
+                <a:effectLst/>
+                <a:latin typeface="+mn-lt"/>
+                <a:ea typeface="+mn-ea"/>
+                <a:cs typeface="+mn-cs"/>
+              </a:rPr>
+              <a:t> </a:t>
+            </a:r>
+            <a:r>
+              <a:rPr lang="en-ID" sz="1200" b="0" i="0" kern="1200" dirty="0" err="1">
+                <a:solidFill>
+                  <a:schemeClr val="tx1"/>
+                </a:solidFill>
+                <a:effectLst/>
+                <a:latin typeface="+mn-lt"/>
+                <a:ea typeface="+mn-ea"/>
+                <a:cs typeface="+mn-cs"/>
+              </a:rPr>
+              <a:t>ke</a:t>
+            </a:r>
+            <a:r>
+              <a:rPr lang="en-ID" sz="1200" b="0" i="0" kern="1200" dirty="0">
+                <a:solidFill>
+                  <a:schemeClr val="tx1"/>
+                </a:solidFill>
+                <a:effectLst/>
+                <a:latin typeface="+mn-lt"/>
+                <a:ea typeface="+mn-ea"/>
+                <a:cs typeface="+mn-cs"/>
+              </a:rPr>
+              <a:t> Wireshark. Saya </a:t>
             </a:r>
             <a:r>
               <a:rPr lang="en-ID" sz="1200" b="0" i="0" kern="1200" dirty="0" err="1">
@@ -14827,19 +15274,211 @@
                 <a:ea typeface="+mn-ea"/>
                 <a:cs typeface="+mn-cs"/>
               </a:rPr>
-              <a:t>Sekarang</a:t>
-            </a:r>
-            <a:r>
-              <a:rPr lang="en-ID" sz="1200" b="0" i="0" kern="1200" dirty="0">
-                <a:solidFill>
-                  <a:schemeClr val="tx1"/>
-                </a:solidFill>
-                <a:effectLst/>
-                <a:latin typeface="+mn-lt"/>
-                <a:ea typeface="+mn-ea"/>
-                <a:cs typeface="+mn-cs"/>
-              </a:rPr>
-              <a:t> </a:t>
+              <a:t>Begitu</a:t>
+            </a:r>
+            <a:r>
+              <a:rPr lang="en-ID" sz="1200" b="0" i="0" kern="1200" dirty="0">
+                <a:solidFill>
+                  <a:schemeClr val="tx1"/>
+                </a:solidFill>
+                <a:effectLst/>
+                <a:latin typeface="+mn-lt"/>
+                <a:ea typeface="+mn-ea"/>
+                <a:cs typeface="+mn-cs"/>
+              </a:rPr>
+              <a:t> </a:t>
+            </a:r>
+            <a:r>
+              <a:rPr lang="en-ID" sz="1200" b="0" i="0" kern="1200" dirty="0" err="1">
+                <a:solidFill>
+                  <a:schemeClr val="tx1"/>
+                </a:solidFill>
+                <a:effectLst/>
+                <a:latin typeface="+mn-lt"/>
+                <a:ea typeface="+mn-ea"/>
+                <a:cs typeface="+mn-cs"/>
+              </a:rPr>
+              <a:t>pesan</a:t>
+            </a:r>
+            <a:r>
+              <a:rPr lang="en-ID" sz="1200" b="0" i="0" kern="1200" dirty="0">
+                <a:solidFill>
+                  <a:schemeClr val="tx1"/>
+                </a:solidFill>
+                <a:effectLst/>
+                <a:latin typeface="+mn-lt"/>
+                <a:ea typeface="+mn-ea"/>
+                <a:cs typeface="+mn-cs"/>
+              </a:rPr>
+              <a:t> </a:t>
+            </a:r>
+            <a:r>
+              <a:rPr lang="en-ID" sz="1200" b="0" i="0" kern="1200" dirty="0" err="1">
+                <a:solidFill>
+                  <a:schemeClr val="tx1"/>
+                </a:solidFill>
+                <a:effectLst/>
+                <a:latin typeface="+mn-lt"/>
+                <a:ea typeface="+mn-ea"/>
+                <a:cs typeface="+mn-cs"/>
+              </a:rPr>
+              <a:t>dikirim</a:t>
+            </a:r>
+            <a:r>
+              <a:rPr lang="en-ID" sz="1200" b="0" i="0" kern="1200" dirty="0">
+                <a:solidFill>
+                  <a:schemeClr val="tx1"/>
+                </a:solidFill>
+                <a:effectLst/>
+                <a:latin typeface="+mn-lt"/>
+                <a:ea typeface="+mn-ea"/>
+                <a:cs typeface="+mn-cs"/>
+              </a:rPr>
+              <a:t>, </a:t>
+            </a:r>
+            <a:r>
+              <a:rPr lang="en-ID" sz="1200" b="0" i="0" kern="1200" dirty="0" err="1">
+                <a:solidFill>
+                  <a:schemeClr val="tx1"/>
+                </a:solidFill>
+                <a:effectLst/>
+                <a:latin typeface="+mn-lt"/>
+                <a:ea typeface="+mn-ea"/>
+                <a:cs typeface="+mn-cs"/>
+              </a:rPr>
+              <a:t>jendela</a:t>
+            </a:r>
+            <a:r>
+              <a:rPr lang="en-ID" sz="1200" b="0" i="0" kern="1200" dirty="0">
+                <a:solidFill>
+                  <a:schemeClr val="tx1"/>
+                </a:solidFill>
+                <a:effectLst/>
+                <a:latin typeface="+mn-lt"/>
+                <a:ea typeface="+mn-ea"/>
+                <a:cs typeface="+mn-cs"/>
+              </a:rPr>
+              <a:t> Wireshark </a:t>
+            </a:r>
+            <a:r>
+              <a:rPr lang="en-ID" sz="1200" b="0" i="0" kern="1200" dirty="0" err="1">
+                <a:solidFill>
+                  <a:schemeClr val="tx1"/>
+                </a:solidFill>
+                <a:effectLst/>
+                <a:latin typeface="+mn-lt"/>
+                <a:ea typeface="+mn-ea"/>
+                <a:cs typeface="+mn-cs"/>
+              </a:rPr>
+              <a:t>otomatis</a:t>
+            </a:r>
+            <a:r>
+              <a:rPr lang="en-ID" sz="1200" b="0" i="0" kern="1200" dirty="0">
+                <a:solidFill>
+                  <a:schemeClr val="tx1"/>
+                </a:solidFill>
+                <a:effectLst/>
+                <a:latin typeface="+mn-lt"/>
+                <a:ea typeface="+mn-ea"/>
+                <a:cs typeface="+mn-cs"/>
+              </a:rPr>
+              <a:t> </a:t>
+            </a:r>
+            <a:r>
+              <a:rPr lang="en-ID" sz="1200" b="0" i="0" kern="1200" dirty="0" err="1">
+                <a:solidFill>
+                  <a:schemeClr val="tx1"/>
+                </a:solidFill>
+                <a:effectLst/>
+                <a:latin typeface="+mn-lt"/>
+                <a:ea typeface="+mn-ea"/>
+                <a:cs typeface="+mn-cs"/>
+              </a:rPr>
+              <a:t>menampilkan</a:t>
+            </a:r>
+            <a:r>
+              <a:rPr lang="en-ID" sz="1200" b="0" i="0" kern="1200" dirty="0">
+                <a:solidFill>
+                  <a:schemeClr val="tx1"/>
+                </a:solidFill>
+                <a:effectLst/>
+                <a:latin typeface="+mn-lt"/>
+                <a:ea typeface="+mn-ea"/>
+                <a:cs typeface="+mn-cs"/>
+              </a:rPr>
+              <a:t> </a:t>
+            </a:r>
+            <a:r>
+              <a:rPr lang="en-ID" sz="1200" b="0" i="0" kern="1200" dirty="0" err="1">
+                <a:solidFill>
+                  <a:schemeClr val="tx1"/>
+                </a:solidFill>
+                <a:effectLst/>
+                <a:latin typeface="+mn-lt"/>
+                <a:ea typeface="+mn-ea"/>
+                <a:cs typeface="+mn-cs"/>
+              </a:rPr>
+              <a:t>paket</a:t>
+            </a:r>
+            <a:r>
+              <a:rPr lang="en-ID" sz="1200" b="0" i="0" kern="1200" dirty="0">
+                <a:solidFill>
+                  <a:schemeClr val="tx1"/>
+                </a:solidFill>
+                <a:effectLst/>
+                <a:latin typeface="+mn-lt"/>
+                <a:ea typeface="+mn-ea"/>
+                <a:cs typeface="+mn-cs"/>
+              </a:rPr>
+              <a:t> yang </a:t>
+            </a:r>
+            <a:r>
+              <a:rPr lang="en-ID" sz="1200" b="0" i="0" kern="1200" dirty="0" err="1">
+                <a:solidFill>
+                  <a:schemeClr val="tx1"/>
+                </a:solidFill>
+                <a:effectLst/>
+                <a:latin typeface="+mn-lt"/>
+                <a:ea typeface="+mn-ea"/>
+                <a:cs typeface="+mn-cs"/>
+              </a:rPr>
+              <a:t>lewat</a:t>
+            </a:r>
+            <a:r>
+              <a:rPr lang="en-ID" sz="1200" b="0" i="0" kern="1200" dirty="0">
+                <a:solidFill>
+                  <a:schemeClr val="tx1"/>
+                </a:solidFill>
+                <a:effectLst/>
+                <a:latin typeface="+mn-lt"/>
+                <a:ea typeface="+mn-ea"/>
+                <a:cs typeface="+mn-cs"/>
+              </a:rPr>
+              <a:t>. Mari </a:t>
+            </a:r>
+            <a:r>
+              <a:rPr lang="en-ID" sz="1200" b="0" i="0" kern="1200" dirty="0" err="1">
+                <a:solidFill>
+                  <a:schemeClr val="tx1"/>
+                </a:solidFill>
+                <a:effectLst/>
+                <a:latin typeface="+mn-lt"/>
+                <a:ea typeface="+mn-ea"/>
+                <a:cs typeface="+mn-cs"/>
+              </a:rPr>
+              <a:t>kita</a:t>
+            </a:r>
+            <a:r>
+              <a:rPr lang="en-ID" sz="1200" b="0" i="0" kern="1200" dirty="0">
+                <a:solidFill>
+                  <a:schemeClr val="tx1"/>
+                </a:solidFill>
+                <a:effectLst/>
+                <a:latin typeface="+mn-lt"/>
+                <a:ea typeface="+mn-ea"/>
+                <a:cs typeface="+mn-cs"/>
+              </a:rPr>
+              <a:t> Follow TCP Stream — dan </a:t>
             </a:r>
             <a:r>
               <a:rPr lang="en-ID" sz="1200" b="0" i="0" kern="1200" dirty="0" err="1">
@@ -14863,7 +15502,7 @@
                 <a:ea typeface="+mn-ea"/>
                 <a:cs typeface="+mn-cs"/>
               </a:rPr>
-              <a:t> Wireshark — Follow TCP Stream — dan </a:t>
+              <a:t>, </a:t>
             </a:r>
             <a:r>
               <a:rPr lang="en-ID" sz="1200" b="0" i="0" kern="1200" dirty="0" err="1">

</xml_diff>